<commit_message>
Point the capstone deck at the published StudyCite app.
The first app's live demo is the Amplify host, with screenshots of that build, and App Runner stays a config file rather than the address that answers.

Co-authored-by: zengpu29 <zengpu29@gmail.com>
</commit_message>
<xml_diff>
--- a/STUDYCITE_BITEWISE_CAPSTONE.pptx
+++ b/STUDYCITE_BITEWISE_CAPSTONE.pptx
@@ -525,13 +525,19 @@
           <a:lstStyle/>
           <a:p>
             <a:r>
-              <a:t>Open with both names and both addresses before any architecture. StudyCite is the first app. Its live prototype is still at triallens-ai.ai.studio and still wears the working title TrialLens AI. The React repository was renamed StudyCite. BiteWise is the second app, public at bitewise-ai.ai.studio.</a:t>
+              <a:t>Open with both names and both addresses before any architecture. StudyCite is the first app, published at https://main.d18cernwuahm9n.amplifyapp.com/. I checked it on October 19, 2026. It returns HTTP 200, the title is StudyCite, and the response is served from Amazon S3 through CloudFront. Last-Modified on that object was September 24, 2026. The page is the React app, not the old single-file host.</a:t>
             </a:r>
           </a:p>
           <a:p/>
           <a:p>
             <a:r>
-              <a:t>Do not claim an awsapprunner.com address for either app. StudyCite has an apprunner.yaml and a verified AWS CLI identity in us-west-2. It does not have a recorded public App Runner URL. BiteWise was published through Google AI Studio because App Runner is closed to new customers.</a:t>
+              <a:t>An earlier single-file prototype is still at triallens-ai.ai.studio and still says TrialLens AI. That is Workshop 1. It is not the live demo for this deck.</a:t>
+            </a:r>
+          </a:p>
+          <a:p/>
+          <a:p>
+            <a:r>
+              <a:t>Do not call the Amplify host App Runner. apprunner.yaml is in the repository, and an AWS CLI identity check succeeded in us-west-2, but the address that answers is Amplify. BiteWise is the second app, public at bitewise-ai.ai.studio, published through Google AI Studio because App Runner is closed to new customers.</a:t>
             </a:r>
           </a:p>
           <a:p/>
@@ -613,13 +619,13 @@
           <a:p/>
           <a:p>
             <a:r>
-              <a:t>The gold set is real content in seed.ts. Answerable examples include the platelet threshold, the Week 4 visit window, IP storage at 2°C to 8°C, renal impairment, SAE reporting within 24 hours, and inverting PK tubes 8 to 10 times. The version trap is 80,000 per microliter. The abstention case is a coronary bypass technique.</a:t>
+              <a:t>The screenshot is the Evaluation page on the Amplify host. It shows eight gold-standard cases and seven gate cards: 93 percent precision at 5, 97 percent citation correctness, 96 percent grounded answers, 0.8 percent unsupported claims, 1.9 seconds median latency, 64 percent search-time reduction, and 4.3 out of 5 satisfaction. Every card says gate met. Those numbers are hardcoded in seed.ts. Say that plainly. They are the demonstration gate on the published app, not an independent measurement. The chip that says GCP quality gate active is interface copy, not a certification.</a:t>
             </a:r>
           </a:p>
           <a:p/>
           <a:p>
             <a:r>
-              <a:t>The Evaluation page renders seven KPI cards with observed values such as 93 percent precision at 5, 97 percent citation correctness, 1.9 seconds median latency, and 4.3 out of 5 satisfaction. Those numbers are hardcoded in seed.ts and every card is marked met. Say that plainly if someone asks for the metrics. They are the demonstration gate, not an independent measurement. The manual checklist in the report is a list of controls to exercise. I am not claiming a recorded pass rate for that list.</a:t>
+              <a:t>The gold questions include the platelet threshold, the Week 4 visit window, IP storage, renal impairment, SAE reporting, PK tube inversion, the 80,000 per microliter version trap, and a coronary bypass question that must abstain. The manual checklist in the September 16 report is a list of controls to exercise. I am not claiming a recorded pass rate for that list.</a:t>
             </a:r>
           </a:p>
         </p:txBody>
@@ -689,25 +695,25 @@
           <a:lstStyle/>
           <a:p>
             <a:r>
-              <a:t>Be direct about Workshop 3. The assignment asked for an AWS App Runner deployment and a live App Runner demo link. What I can show is the configuration and the identity check. What I cannot show is a running App Runner service URL, because the StudyCite README does not record one, and I will not fabricate an awsapprunner.com address or a console screenshot.</a:t>
+              <a:t>Be direct about Workshop 3. The assignment asked for App Runner. The address that answers is AWS Amplify: https://main.d18cernwuahm9n.amplifyapp.com/. On October 19, 2026 the response was HTTP 200, server Amazon S3, via CloudFront. The HTML object was last modified September 24, 2026. The title is StudyCite, clinical trial knowledge assistant. Referrer policy on the page is strict-origin-when-cross-origin.</a:t>
             </a:r>
           </a:p>
           <a:p/>
           <a:p>
             <a:r>
-              <a:t>The AWS note from September 19, 2026 says CLI version 2 was installed, the default region is us-west-2, and GetCallerIdentity succeeded for an IAM user. Do not read the account number, user id, or access-key suffix aloud. They are not needed to make the point.</a:t>
+              <a:t>amplify.yml installs with npm ci, builds with npm run build, and publishes the dist directory. That matches a static Vite app. It does not add FastAPI, pgvector, or Cognito.</a:t>
             </a:r>
           </a:p>
           <a:p/>
           <a:p>
             <a:r>
-              <a:t>apprunner.yaml is in the repository: runtime nodejs22, build commands npm ci and npm run build, run command npm run preview on host 0.0.0.0 port 8080, network port 8080. There is also a Dockerfile and an amplify.yml. The preview command serves the static React app. It does not add a Python API.</a:t>
+              <a:t>apprunner.yaml is still in the repository: Node 22, npm ci, npm run build, then Vite preview on port 8080. There is no awsapprunner.com hostname to open. Do not invent one, and do not read the AWS account number aloud. The identity check in us-west-2 only proves the CLI could authenticate.</a:t>
             </a:r>
           </a:p>
           <a:p/>
           <a:p>
             <a:r>
-              <a:t>The live demo link for Application 1 is the prototype: https://triallens-ai.ai.studio.</a:t>
+              <a:t>The live demo link for Application 1 is the Amplify URL. The old single-file host is a separate, earlier artifact.</a:t>
             </a:r>
           </a:p>
         </p:txBody>
@@ -777,19 +783,19 @@
           <a:lstStyle/>
           <a:p>
             <a:r>
-              <a:t>Four challenges, each with a consequence. First, I will not demo a service I cannot open. Second, the reflection records that the hosted prototype was not always reachable, which is why the local build used the specification plus screenshots. Third, do not let the App Runner file be described as the Phase 2 architecture. Fourth, if the live page says TrialLens AI, that is expected. The rename is in the repository.</a:t>
+              <a:t>Four challenges, each with a consequence. First, the App Runner file is not the service I can open. The service I can open is Amplify. Second, during the IDE conversion the single-file prototype was sometimes unreachable, which is why the local build used the specification plus screenshots. Third, do not describe this CloudFront site as the Phase 2 stack. Documents on the published app still show the rule in the browser: TL-301 protocol v3.0 is Approved, and v2.0 is Superseded. Fourth, if someone opens triallens-ai.ai.studio and sees TrialLens AI, that is the old host. The Amplify app is named StudyCite.</a:t>
             </a:r>
           </a:p>
           <a:p/>
           <a:p>
             <a:r>
-              <a:t>The useful comparison for later: BiteWise has one public URL where the page and the API are the same host. StudyCite's runnable demo and StudyCite's repository are still two different things.</a:t>
+              <a:t>BiteWise later put the page and the API on one host. StudyCite's public host is the static app only.</a:t>
             </a:r>
           </a:p>
           <a:p/>
           <a:p>
             <a:r>
-              <a:t>If asked what I would redeploy, the answer is a server that enforces approved-only retrieval, not a second static preview.</a:t>
+              <a:t>If asked what I would redeploy, the answer is a server that enforces approved-only retrieval, not another static copy.</a:t>
             </a:r>
           </a:p>
         </p:txBody>
@@ -1481,7 +1487,7 @@
           <a:p/>
           <a:p>
             <a:r>
-              <a:t>The four figures are documented, not estimated. StudyCite seed data holds eight gold-standard cases: six answerable, one version trap, one abstention. The September 16, 2026 testing report lists seven defects that were fixed in that pass. BiteWise has twelve API tests in tests/api.test.js, and that file passes. The two hosts that answer are triallens-ai.ai.studio and bitewise-ai.ai.studio.</a:t>
+              <a:t>The four figures are documented, not estimated. StudyCite seed data holds eight gold-standard cases: six answerable, one version trap, one abstention. The September 16, 2026 testing report lists seven defects that were fixed in that pass. BiteWise has twelve API tests in tests/api.test.js, and that file passes. The two hosts that answer are the Amplify StudyCite app and bitewise-ai.ai.studio.</a:t>
             </a:r>
           </a:p>
           <a:p/>
@@ -1821,7 +1827,7 @@
           <a:p/>
           <a:p>
             <a:r>
-              <a:t>Say the cost side without drama. I am not quoting an AWS bill, because StudyCite has no recorded public App Runner service and BiteWise's publish path is AI Studio's starter hosting. I will not invent a monthly price.</a:t>
+              <a:t>Say the cost side without drama. I am not quoting an AWS bill for the Amplify app, and I am not quoting an AI Studio price for BiteWise. I will not invent a monthly figure.</a:t>
             </a:r>
           </a:p>
           <a:p/>
@@ -1909,13 +1915,13 @@
           <a:p/>
           <a:p>
             <a:r>
-              <a:t>End by opening one of the two links if the room has a network connection. For StudyCite, the page will say TrialLens AI. For BiteWise, run a vegetarian request under $15 and read the badge: Gemini or fallback. Either badge is a successful demo if the meals on the cards were eligible.</a:t>
+              <a:t>End by opening the Amplify link if the room has a network connection. The page should say StudyCite, not TrialLens AI, and the study selector should show TL-301 Phase III. Then open BiteWise and run a vegetarian request under $15. Read the badge: Gemini or fallback. Either badge is a successful demo if every meal on the cards was eligible.</a:t>
             </a:r>
           </a:p>
           <a:p/>
           <a:p>
             <a:r>
-              <a:t>Thank the room. Questions are welcome on the bug list, the twelve tests, and why there is no App Runner URL.</a:t>
+              <a:t>Thank the room. Questions are welcome on the bug list, the twelve tests, and why this host is Amplify rather than App Runner.</a:t>
             </a:r>
           </a:p>
         </p:txBody>
@@ -2231,25 +2237,25 @@
           <a:lstStyle/>
           <a:p>
             <a:r>
-              <a:t>Click the screenshot only to show that the prototype is real. The address is https://triallens-ai.ai.studio. I checked it on October 18, 2026: HTTP 200, served behind Google Frontend. Last-Modified on an earlier check was September 7, 2026.</a:t>
+              <a:t>The screenshot is the first app at https://main.d18cernwuahm9n.amplifyapp.com/, captured October 19, 2026. The header says StudyCite, v1.0 RAG. The active study is TL-301 Phase III, v3.0 Approved, code TL-301-NSCLC. The role shown is ClinOps Lead. The sample card cites Clinical Protocol TL-301, Section 5.3, page 38, Approved v3.0, for the platelet threshold of at least 100,000 per microliter.</a:t>
             </a:r>
           </a:p>
           <a:p/>
           <a:p>
             <a:r>
-              <a:t>The page still uses the working title TrialLens AI. The reflection explains the rename: Clinical ink already uses TrialLens, and "lens" does not describe the job. StudyCite names the rule that every answer must be citable against the current approved source.</a:t>
+              <a:t>Workshop 1 was the single-file host at triallens-ai.ai.studio. That page still uses the working title TrialLens AI. Clinical ink already uses TrialLens, and "lens" does not describe the job. StudyCite names the citation rule. Do not present the old host as this deployment.</a:t>
             </a:r>
           </a:p>
           <a:p/>
           <a:p>
             <a:r>
-              <a:t>Do not read the hero line — 100 percent grounded, 0 percent black-box guesses, under 2 seconds — as a result. The same caution applies to the confidence badge in the sample card. Point at the workflow instead: a protocol question, a grounded answer, and a citation to Protocol TL-301, Section 5.3.</a:t>
+              <a:t>Do not read the overview figures — 100 percent grounded, 0 percent black-box guesses, under 2 seconds — as results. Point at the workflow: a protocol question, a grounded answer, and a citation.</a:t>
             </a:r>
           </a:p>
           <a:p/>
           <a:p>
             <a:r>
-              <a:t>Claude-style single-file hosting, including this AI Studio host, was the right Workshop 1 surface. It was the wrong place to finish.</a:t>
+              <a:t>The Amplify app is the static React build. Retrieval still runs in the browser. Say that before anyone treats CloudFront as the Phase 2 backend.</a:t>
             </a:r>
           </a:p>
         </p:txBody>
@@ -2413,7 +2419,7 @@
           <a:p/>
           <a:p>
             <a:r>
-              <a:t>There is no backend process. The apprunner.yaml later serves the built Vite preview, which is still this frontend. Do not describe FastAPI or pgvector as deployed.</a:t>
+              <a:t>There is no API server in this deployment. AWS Amplify publishes the Vite build to S3 behind CloudFront. apprunner.yaml is a different file and is not this hostname. Do not describe FastAPI or pgvector as deployed.</a:t>
             </a:r>
           </a:p>
           <a:p/>
@@ -5764,7 +5770,7 @@
                 </a:solidFill>
                 <a:latin typeface="Calibri"/>
               </a:rPr>
-              <a:t>October 18, 2026</a:t>
+              <a:t>October 19, 2026</a:t>
             </a:r>
           </a:p>
         </p:txBody>
@@ -5777,8 +5783,8 @@
         </p:nvSpPr>
         <p:spPr>
           <a:xfrm>
-            <a:off x="658368" y="4892040"/>
-            <a:ext cx="5212080" cy="1234440"/>
+            <a:off x="658368" y="4773168"/>
+            <a:ext cx="5623560" cy="1417320"/>
           </a:xfrm>
           <a:prstGeom prst="roundRect">
             <a:avLst>
@@ -5810,8 +5816,8 @@
         </p:nvSpPr>
         <p:spPr>
           <a:xfrm>
-            <a:off x="841248" y="5010912"/>
-            <a:ext cx="4846320" cy="256032"/>
+            <a:off x="841248" y="4882896"/>
+            <a:ext cx="5303520" cy="237744"/>
           </a:xfrm>
           <a:prstGeom prst="rect">
             <a:avLst/>
@@ -5837,7 +5843,7 @@
                 </a:solidFill>
                 <a:latin typeface="Calibri"/>
               </a:rPr>
-              <a:t>STUDYCITE PROTOTYPE</a:t>
+              <a:t>STUDYCITE  ·  AWS AMPLIFY</a:t>
             </a:r>
           </a:p>
         </p:txBody>
@@ -5850,8 +5856,8 @@
         </p:nvSpPr>
         <p:spPr>
           <a:xfrm>
-            <a:off x="841248" y="5285232"/>
-            <a:ext cx="4846320" cy="292608"/>
+            <a:off x="841248" y="5157216"/>
+            <a:ext cx="5303520" cy="530352"/>
           </a:xfrm>
           <a:prstGeom prst="rect">
             <a:avLst/>
@@ -5871,13 +5877,13 @@
               </a:spcAft>
             </a:pPr>
             <a:r>
-              <a:rPr sz="1800" b="1">
+              <a:rPr sz="1500" b="1">
                 <a:solidFill>
                   <a:srgbClr val="FFFFFF"/>
                 </a:solidFill>
                 <a:latin typeface="Calibri"/>
               </a:rPr>
-              <a:t>triallens-ai.ai.studio</a:t>
+              <a:t>main.d18cernwuahm9n.amplifyapp.com</a:t>
             </a:r>
           </a:p>
         </p:txBody>
@@ -5890,8 +5896,8 @@
         </p:nvSpPr>
         <p:spPr>
           <a:xfrm>
-            <a:off x="841248" y="5632704"/>
-            <a:ext cx="4846320" cy="329184"/>
+            <a:off x="841248" y="5742432"/>
+            <a:ext cx="5303520" cy="329184"/>
           </a:xfrm>
           <a:prstGeom prst="rect">
             <a:avLst/>
@@ -5917,7 +5923,7 @@
                 </a:solidFill>
                 <a:latin typeface="Calibri"/>
               </a:rPr>
-              <a:t>Single-file host. Still titled TrialLens AI.</a:t>
+              <a:t>The React app. CloudFront in front of the build.</a:t>
             </a:r>
           </a:p>
         </p:txBody>
@@ -5930,8 +5936,8 @@
         </p:nvSpPr>
         <p:spPr>
           <a:xfrm>
-            <a:off x="6126480" y="4892040"/>
-            <a:ext cx="5394960" cy="1234440"/>
+            <a:off x="6446520" y="4773168"/>
+            <a:ext cx="5074920" cy="1417320"/>
           </a:xfrm>
           <a:prstGeom prst="roundRect">
             <a:avLst>
@@ -5963,8 +5969,8 @@
         </p:nvSpPr>
         <p:spPr>
           <a:xfrm>
-            <a:off x="6309360" y="5010912"/>
-            <a:ext cx="5029200" cy="256032"/>
+            <a:off x="6629400" y="4882896"/>
+            <a:ext cx="4754880" cy="237744"/>
           </a:xfrm>
           <a:prstGeom prst="rect">
             <a:avLst/>
@@ -6003,8 +6009,8 @@
         </p:nvSpPr>
         <p:spPr>
           <a:xfrm>
-            <a:off x="6309360" y="5285232"/>
-            <a:ext cx="5029200" cy="292608"/>
+            <a:off x="6629400" y="5193792"/>
+            <a:ext cx="4754880" cy="329184"/>
           </a:xfrm>
           <a:prstGeom prst="rect">
             <a:avLst/>
@@ -6043,8 +6049,8 @@
         </p:nvSpPr>
         <p:spPr>
           <a:xfrm>
-            <a:off x="6309360" y="5632704"/>
-            <a:ext cx="5029200" cy="329184"/>
+            <a:off x="6629400" y="5742432"/>
+            <a:ext cx="4754880" cy="329184"/>
           </a:xfrm>
           <a:prstGeom prst="rect">
             <a:avLst/>
@@ -6596,39 +6602,30 @@
           </a:p>
         </p:txBody>
       </p:sp>
-      <p:sp>
-        <p:nvSpPr>
-          <p:cNvPr id="13" name="Rounded Rectangle 12"/>
-          <p:cNvSpPr/>
-          <p:nvPr/>
-        </p:nvSpPr>
-        <p:spPr>
-          <a:xfrm>
-            <a:off x="7424927" y="1261872"/>
-            <a:ext cx="4343400" cy="5029200"/>
-          </a:xfrm>
-          <a:prstGeom prst="roundRect">
-            <a:avLst>
-              <a:gd name="adj" fmla="val 8000"/>
-            </a:avLst>
-          </a:prstGeom>
-          <a:solidFill>
-            <a:srgbClr val="FFFFFF"/>
-          </a:solidFill>
-          <a:ln w="12700">
-            <a:solidFill>
-              <a:srgbClr val="E4DBCE"/>
-            </a:solidFill>
-          </a:ln>
-        </p:spPr>
-        <p:txBody>
-          <a:bodyPr rtlCol="0" anchor="ctr"/>
-          <a:lstStyle/>
-          <a:p>
-            <a:pPr algn="ctr"/>
-          </a:p>
-        </p:txBody>
-      </p:sp>
+      <p:pic>
+        <p:nvPicPr>
+          <p:cNvPr id="13" name="Picture 12" descr="studycite-evaluation.png"/>
+          <p:cNvPicPr>
+            <a:picLocks noChangeAspect="1"/>
+          </p:cNvPicPr>
+          <p:nvPr/>
+        </p:nvPicPr>
+        <p:blipFill>
+          <a:blip r:embed="rId2"/>
+          <a:stretch>
+            <a:fillRect/>
+          </a:stretch>
+        </p:blipFill>
+        <p:spPr>
+          <a:xfrm>
+            <a:off x="7452360" y="1261872"/>
+            <a:ext cx="4297680" cy="2688336"/>
+          </a:xfrm>
+          <a:prstGeom prst="rect">
+            <a:avLst/>
+          </a:prstGeom>
+        </p:spPr>
+      </p:pic>
       <p:sp>
         <p:nvSpPr>
           <p:cNvPr id="14" name="TextBox 13"/>
@@ -6637,8 +6634,8 @@
         </p:nvSpPr>
         <p:spPr>
           <a:xfrm>
-            <a:off x="7607808" y="1389888"/>
-            <a:ext cx="4023360" cy="292608"/>
+            <a:off x="7452360" y="4023360"/>
+            <a:ext cx="4297680" cy="2103120"/>
           </a:xfrm>
           <a:prstGeom prst="rect">
             <a:avLst/>
@@ -6658,253 +6655,13 @@
               </a:spcAft>
             </a:pPr>
             <a:r>
-              <a:rPr sz="1400" b="1">
-                <a:solidFill>
-                  <a:srgbClr val="1A6A64"/>
-                </a:solidFill>
-                <a:latin typeface="Calibri"/>
-              </a:rPr>
-              <a:t>Evidence</a:t>
-            </a:r>
-          </a:p>
-        </p:txBody>
-      </p:sp>
-      <p:sp>
-        <p:nvSpPr>
-          <p:cNvPr id="15" name="TextBox 14"/>
-          <p:cNvSpPr txBox="1"/>
-          <p:nvPr/>
-        </p:nvSpPr>
-        <p:spPr>
-          <a:xfrm>
-            <a:off x="7607808" y="1874519"/>
-            <a:ext cx="3977639" cy="329184"/>
-          </a:xfrm>
-          <a:prstGeom prst="rect">
-            <a:avLst/>
-          </a:prstGeom>
-          <a:noFill/>
-        </p:spPr>
-        <p:txBody>
-          <a:bodyPr wrap="square" anchor="t"/>
-          <a:lstStyle/>
-          <a:p>
-            <a:pPr algn="l">
-              <a:spcBef>
-                <a:spcPts val="0"/>
-              </a:spcBef>
-              <a:spcAft>
-                <a:spcPts val="0"/>
-              </a:spcAft>
-            </a:pPr>
-            <a:r>
-              <a:rPr sz="1800" b="1">
-                <a:solidFill>
-                  <a:srgbClr val="142238"/>
-                </a:solidFill>
-                <a:latin typeface="Calibri"/>
-              </a:rPr>
-              <a:t>8</a:t>
-            </a:r>
-          </a:p>
-        </p:txBody>
-      </p:sp>
-      <p:sp>
-        <p:nvSpPr>
-          <p:cNvPr id="16" name="TextBox 15"/>
-          <p:cNvSpPr txBox="1"/>
-          <p:nvPr/>
-        </p:nvSpPr>
-        <p:spPr>
-          <a:xfrm>
-            <a:off x="7607808" y="2240279"/>
-            <a:ext cx="3977639" cy="822960"/>
-          </a:xfrm>
-          <a:prstGeom prst="rect">
-            <a:avLst/>
-          </a:prstGeom>
-          <a:noFill/>
-        </p:spPr>
-        <p:txBody>
-          <a:bodyPr wrap="square" anchor="t"/>
-          <a:lstStyle/>
-          <a:p>
-            <a:pPr algn="l">
-              <a:spcBef>
-                <a:spcPts val="0"/>
-              </a:spcBef>
-              <a:spcAft>
-                <a:spcPts val="0"/>
-              </a:spcAft>
-            </a:pPr>
-            <a:r>
               <a:rPr sz="1300" b="0">
                 <a:solidFill>
-                  <a:srgbClr val="1C222B"/>
-                </a:solidFill>
-                <a:latin typeface="Calibri"/>
-              </a:rPr>
-              <a:t>Gold cases: 6 answerable, 1 version trap, 1 abstention.</a:t>
-            </a:r>
-          </a:p>
-        </p:txBody>
-      </p:sp>
-      <p:sp>
-        <p:nvSpPr>
-          <p:cNvPr id="17" name="TextBox 16"/>
-          <p:cNvSpPr txBox="1"/>
-          <p:nvPr/>
-        </p:nvSpPr>
-        <p:spPr>
-          <a:xfrm>
-            <a:off x="7607808" y="3200400"/>
-            <a:ext cx="3977639" cy="329184"/>
-          </a:xfrm>
-          <a:prstGeom prst="rect">
-            <a:avLst/>
-          </a:prstGeom>
-          <a:noFill/>
-        </p:spPr>
-        <p:txBody>
-          <a:bodyPr wrap="square" anchor="t"/>
-          <a:lstStyle/>
-          <a:p>
-            <a:pPr algn="l">
-              <a:spcBef>
-                <a:spcPts val="0"/>
-              </a:spcBef>
-              <a:spcAft>
-                <a:spcPts val="0"/>
-              </a:spcAft>
-            </a:pPr>
-            <a:r>
-              <a:rPr sz="1800" b="1">
-                <a:solidFill>
-                  <a:srgbClr val="142238"/>
-                </a:solidFill>
-                <a:latin typeface="Calibri"/>
-              </a:rPr>
-              <a:t>5</a:t>
-            </a:r>
-          </a:p>
-        </p:txBody>
-      </p:sp>
-      <p:sp>
-        <p:nvSpPr>
-          <p:cNvPr id="18" name="TextBox 17"/>
-          <p:cNvSpPr txBox="1"/>
-          <p:nvPr/>
-        </p:nvSpPr>
-        <p:spPr>
-          <a:xfrm>
-            <a:off x="7607808" y="3566160"/>
-            <a:ext cx="3977639" cy="822960"/>
-          </a:xfrm>
-          <a:prstGeom prst="rect">
-            <a:avLst/>
-          </a:prstGeom>
-          <a:noFill/>
-        </p:spPr>
-        <p:txBody>
-          <a:bodyPr wrap="square" anchor="t"/>
-          <a:lstStyle/>
-          <a:p>
-            <a:pPr algn="l">
-              <a:spcBef>
-                <a:spcPts val="0"/>
-              </a:spcBef>
-              <a:spcAft>
-                <a:spcPts val="0"/>
-              </a:spcAft>
-            </a:pPr>
-            <a:r>
-              <a:rPr sz="1300" b="0">
-                <a:solidFill>
-                  <a:srgbClr val="1C222B"/>
-                </a:solidFill>
-                <a:latin typeface="Calibri"/>
-              </a:rPr>
-              <a:t>Pages covered by the manual checklist, plus an unknown-URL redirect.</a:t>
-            </a:r>
-          </a:p>
-        </p:txBody>
-      </p:sp>
-      <p:sp>
-        <p:nvSpPr>
-          <p:cNvPr id="19" name="TextBox 18"/>
-          <p:cNvSpPr txBox="1"/>
-          <p:nvPr/>
-        </p:nvSpPr>
-        <p:spPr>
-          <a:xfrm>
-            <a:off x="7607808" y="4526279"/>
-            <a:ext cx="3977639" cy="329184"/>
-          </a:xfrm>
-          <a:prstGeom prst="rect">
-            <a:avLst/>
-          </a:prstGeom>
-          <a:noFill/>
-        </p:spPr>
-        <p:txBody>
-          <a:bodyPr wrap="square" anchor="t"/>
-          <a:lstStyle/>
-          <a:p>
-            <a:pPr algn="l">
-              <a:spcBef>
-                <a:spcPts val="0"/>
-              </a:spcBef>
-              <a:spcAft>
-                <a:spcPts val="0"/>
-              </a:spcAft>
-            </a:pPr>
-            <a:r>
-              <a:rPr sz="1800" b="1">
-                <a:solidFill>
-                  <a:srgbClr val="142238"/>
-                </a:solidFill>
-                <a:latin typeface="Calibri"/>
-              </a:rPr>
-              <a:t>Seed</a:t>
-            </a:r>
-          </a:p>
-        </p:txBody>
-      </p:sp>
-      <p:sp>
-        <p:nvSpPr>
-          <p:cNvPr id="20" name="TextBox 19"/>
-          <p:cNvSpPr txBox="1"/>
-          <p:nvPr/>
-        </p:nvSpPr>
-        <p:spPr>
-          <a:xfrm>
-            <a:off x="7607808" y="4892040"/>
-            <a:ext cx="3977639" cy="822960"/>
-          </a:xfrm>
-          <a:prstGeom prst="rect">
-            <a:avLst/>
-          </a:prstGeom>
-          <a:noFill/>
-        </p:spPr>
-        <p:txBody>
-          <a:bodyPr wrap="square" anchor="t"/>
-          <a:lstStyle/>
-          <a:p>
-            <a:pPr algn="l">
-              <a:spcBef>
-                <a:spcPts val="0"/>
-              </a:spcBef>
-              <a:spcAft>
-                <a:spcPts val="0"/>
-              </a:spcAft>
-            </a:pPr>
-            <a:r>
-              <a:rPr sz="1300" b="0">
-                <a:solidFill>
-                  <a:srgbClr val="1C222B"/>
-                </a:solidFill>
-                <a:latin typeface="Calibri"/>
-              </a:rPr>
-              <a:t>KPI cards in the UI are demonstration figures, not a field study.</a:t>
+                  <a:srgbClr val="5C6570"/>
+                </a:solidFill>
+                <a:latin typeface="Calibri"/>
+              </a:rPr>
+              <a:t>Published Evaluation page, October 19, 2026. Eight gold cases. The gate cards are seeded demonstration figures, not a field study.</a:t>
             </a:r>
           </a:p>
         </p:txBody>
@@ -7060,7 +6817,7 @@
                 </a:solidFill>
                 <a:latin typeface="Calibri"/>
               </a:rPr>
-              <a:t>An App Runner file, and the URL that answers</a:t>
+              <a:t>Published on Amplify, not on App Runner</a:t>
             </a:r>
           </a:p>
         </p:txBody>
@@ -7522,7 +7279,7 @@
                 </a:solidFill>
                 <a:latin typeface="Calibri"/>
               </a:rPr>
-              <a:t>apprunner.yaml</a:t>
+              <a:t>amplify.yml</a:t>
             </a:r>
           </a:p>
         </p:txBody>
@@ -7562,7 +7319,7 @@
                 </a:solidFill>
                 <a:latin typeface="Calibri"/>
               </a:rPr>
-              <a:t>Node 22. npm ci and npm run build. Then Vite preview on 0.0.0.0 port 8080.</a:t>
+              <a:t>npm ci, then npm run build. The published artifact is the dist folder.</a:t>
             </a:r>
           </a:p>
         </p:txBody>
@@ -7704,7 +7461,7 @@
                 </a:solidFill>
                 <a:latin typeface="Calibri"/>
               </a:rPr>
-              <a:t>What is not recorded</a:t>
+              <a:t>What answers</a:t>
             </a:r>
           </a:p>
         </p:txBody>
@@ -7744,7 +7501,7 @@
                 </a:solidFill>
                 <a:latin typeface="Calibri"/>
               </a:rPr>
-              <a:t>The README has no public App Runner hostname. I will not invent one.</a:t>
+              <a:t>CloudFront in front of S3. HTTP 200 on October 19, 2026. Object last modified September 24.</a:t>
             </a:r>
           </a:p>
         </p:txBody>
@@ -7886,7 +7643,7 @@
                 </a:solidFill>
                 <a:latin typeface="Calibri"/>
               </a:rPr>
-              <a:t>What answers</a:t>
+              <a:t>What App Runner is not</a:t>
             </a:r>
           </a:p>
         </p:txBody>
@@ -7926,7 +7683,7 @@
                 </a:solidFill>
                 <a:latin typeface="Calibri"/>
               </a:rPr>
-              <a:t>The Workshop 1 prototype at triallens-ai.ai.studio still returns the app.</a:t>
+              <a:t>apprunner.yaml still previews Vite on port 8080. That file is not this hostname.</a:t>
             </a:r>
           </a:p>
         </p:txBody>
@@ -8333,7 +8090,7 @@
                 </a:solidFill>
                 <a:latin typeface="Calibri"/>
               </a:rPr>
-              <a:t>App Runner settings are checked in. No public service URL was recorded, so the live demo remains the prototype host.</a:t>
+              <a:t>App Runner settings are checked in. The host that answers is Amplify: CloudFront and S3, not an App Runner URL.</a:t>
             </a:r>
           </a:p>
         </p:txBody>
@@ -8559,7 +8316,7 @@
                 </a:solidFill>
                 <a:latin typeface="Calibri"/>
               </a:rPr>
-              <a:t>Vite preview has no FastAPI, no pgvector, and no Cognito. Shipping the preview would not have made Phase 2 true.</a:t>
+              <a:t>Amplify serves the same static build. It has no FastAPI, no pgvector, and no Cognito. Phase 2 is still a target.</a:t>
             </a:r>
           </a:p>
         </p:txBody>
@@ -8672,7 +8429,7 @@
                 </a:solidFill>
                 <a:latin typeface="Calibri"/>
               </a:rPr>
-              <a:t>TrialLens is already used by Clinical ink. The repository name StudyCite matches the citation rule. The old host still shows the old name.</a:t>
+              <a:t>TrialLens is already used by Clinical ink. The Amplify app says StudyCite. The old single-file host still shows the old name.</a:t>
             </a:r>
           </a:p>
         </p:txBody>
@@ -8706,13 +8463,13 @@
               </a:spcAft>
             </a:pPr>
             <a:r>
-              <a:rPr sz="1800" b="1">
+              <a:rPr sz="1600" b="1">
                 <a:solidFill>
                   <a:srgbClr val="1A6A64"/>
                 </a:solidFill>
                 <a:latin typeface="Calibri"/>
               </a:rPr>
-              <a:t>Live demo for Application 1:  https://triallens-ai.ai.studio</a:t>
+              <a:t>Live demo for Application 1:  https://main.d18cernwuahm9n.amplifyapp.com</a:t>
             </a:r>
           </a:p>
         </p:txBody>
@@ -19019,7 +18776,7 @@
                 </a:solidFill>
                 <a:latin typeface="Calibri"/>
               </a:rPr>
-              <a:t>Prototype host and a separate repository</a:t>
+              <a:t>Amplify hosts the static React app</a:t>
             </a:r>
           </a:p>
         </p:txBody>
@@ -21195,8 +20952,8 @@
         </p:nvSpPr>
         <p:spPr>
           <a:xfrm>
-            <a:off x="640080" y="4709160"/>
-            <a:ext cx="5303520" cy="1325880"/>
+            <a:off x="640080" y="4617720"/>
+            <a:ext cx="5669280" cy="1463040"/>
           </a:xfrm>
           <a:prstGeom prst="roundRect">
             <a:avLst>
@@ -21228,8 +20985,8 @@
         </p:nvSpPr>
         <p:spPr>
           <a:xfrm>
-            <a:off x="822960" y="4828032"/>
-            <a:ext cx="4937760" cy="256032"/>
+            <a:off x="822960" y="4718304"/>
+            <a:ext cx="5349240" cy="237744"/>
           </a:xfrm>
           <a:prstGeom prst="rect">
             <a:avLst/>
@@ -21255,7 +21012,7 @@
                 </a:solidFill>
                 <a:latin typeface="Calibri"/>
               </a:rPr>
-              <a:t>STUDYCITE PROTOTYPE</a:t>
+              <a:t>STUDYCITE  ·  AWS AMPLIFY</a:t>
             </a:r>
           </a:p>
         </p:txBody>
@@ -21268,8 +21025,8 @@
         </p:nvSpPr>
         <p:spPr>
           <a:xfrm>
-            <a:off x="822960" y="5120640"/>
-            <a:ext cx="4937760" cy="320040"/>
+            <a:off x="822960" y="5010912"/>
+            <a:ext cx="5349240" cy="502920"/>
           </a:xfrm>
           <a:prstGeom prst="rect">
             <a:avLst/>
@@ -21289,13 +21046,13 @@
               </a:spcAft>
             </a:pPr>
             <a:r>
-              <a:rPr sz="1800" b="1">
+              <a:rPr sz="1400" b="1">
                 <a:solidFill>
                   <a:srgbClr val="FFFFFF"/>
                 </a:solidFill>
                 <a:latin typeface="Calibri"/>
               </a:rPr>
-              <a:t>triallens-ai.ai.studio</a:t>
+              <a:t>main.d18cernwuahm9n.amplifyapp.com</a:t>
             </a:r>
           </a:p>
         </p:txBody>
@@ -21308,8 +21065,8 @@
         </p:nvSpPr>
         <p:spPr>
           <a:xfrm>
-            <a:off x="822960" y="5532120"/>
-            <a:ext cx="4937760" cy="320040"/>
+            <a:off x="822960" y="5596128"/>
+            <a:ext cx="5349240" cy="329184"/>
           </a:xfrm>
           <a:prstGeom prst="rect">
             <a:avLst/>
@@ -21335,7 +21092,7 @@
                 </a:solidFill>
                 <a:latin typeface="Calibri"/>
               </a:rPr>
-              <a:t>Working title TrialLens AI</a:t>
+              <a:t>React app on CloudFront and S3</a:t>
             </a:r>
           </a:p>
         </p:txBody>
@@ -21348,8 +21105,8 @@
         </p:nvSpPr>
         <p:spPr>
           <a:xfrm>
-            <a:off x="6172200" y="4709160"/>
-            <a:ext cx="5349240" cy="1325880"/>
+            <a:off x="6492240" y="4617720"/>
+            <a:ext cx="5029200" cy="1463040"/>
           </a:xfrm>
           <a:prstGeom prst="roundRect">
             <a:avLst>
@@ -21381,8 +21138,8 @@
         </p:nvSpPr>
         <p:spPr>
           <a:xfrm>
-            <a:off x="6355080" y="4828032"/>
-            <a:ext cx="4983480" cy="256032"/>
+            <a:off x="6675120" y="4718304"/>
+            <a:ext cx="4709160" cy="237744"/>
           </a:xfrm>
           <a:prstGeom prst="rect">
             <a:avLst/>
@@ -21421,8 +21178,8 @@
         </p:nvSpPr>
         <p:spPr>
           <a:xfrm>
-            <a:off x="6355080" y="5120640"/>
-            <a:ext cx="4983480" cy="320040"/>
+            <a:off x="6675120" y="5047488"/>
+            <a:ext cx="4709160" cy="365760"/>
           </a:xfrm>
           <a:prstGeom prst="rect">
             <a:avLst/>
@@ -21442,7 +21199,7 @@
               </a:spcAft>
             </a:pPr>
             <a:r>
-              <a:rPr sz="1800" b="1">
+              <a:rPr sz="1600" b="1">
                 <a:solidFill>
                   <a:srgbClr val="FFFFFF"/>
                 </a:solidFill>
@@ -21461,8 +21218,8 @@
         </p:nvSpPr>
         <p:spPr>
           <a:xfrm>
-            <a:off x="6355080" y="5532120"/>
-            <a:ext cx="4983480" cy="320040"/>
+            <a:off x="6675120" y="5596128"/>
+            <a:ext cx="4709160" cy="329184"/>
           </a:xfrm>
           <a:prstGeom prst="rect">
             <a:avLst/>
@@ -24797,13 +24554,13 @@
               </a:spcAft>
             </a:pPr>
             <a:r>
-              <a:rPr sz="2800" b="1">
+              <a:rPr sz="2600" b="1">
                 <a:solidFill>
                   <a:srgbClr val="142238"/>
                 </a:solidFill>
                 <a:latin typeface="Calibri"/>
               </a:rPr>
-              <a:t>The single-file prototype</a:t>
+              <a:t>The first app, now published</a:t>
             </a:r>
           </a:p>
         </p:txBody>
@@ -24955,7 +24712,7 @@
         <p:spPr>
           <a:xfrm>
             <a:off x="420624" y="1243584"/>
-            <a:ext cx="5212080" cy="777240"/>
+            <a:ext cx="5349240" cy="640080"/>
           </a:xfrm>
           <a:prstGeom prst="rect">
             <a:avLst/>
@@ -24975,13 +24732,13 @@
               </a:spcAft>
             </a:pPr>
             <a:r>
-              <a:rPr sz="1800" b="1">
+              <a:rPr sz="1600" b="1">
                 <a:solidFill>
                   <a:srgbClr val="142238"/>
                 </a:solidFill>
                 <a:latin typeface="Calibri"/>
               </a:rPr>
-              <a:t>A shared URL was the fastest way to see the workflow.</a:t>
+              <a:t>Workshop 1 was one file. This screenshot is the React app that replaced it.</a:t>
             </a:r>
           </a:p>
         </p:txBody>
@@ -24994,8 +24751,8 @@
         </p:nvSpPr>
         <p:spPr>
           <a:xfrm>
-            <a:off x="420624" y="2057400"/>
-            <a:ext cx="5349240" cy="3017520"/>
+            <a:off x="420624" y="1965960"/>
+            <a:ext cx="5349240" cy="3108960"/>
           </a:xfrm>
           <a:prstGeom prst="rect">
             <a:avLst/>
@@ -25011,74 +24768,74 @@
                 <a:spcPts val="0"/>
               </a:spcBef>
               <a:spcAft>
-                <a:spcPts val="900"/>
-              </a:spcAft>
-            </a:pPr>
-            <a:r>
-              <a:rPr sz="1500" b="0">
+                <a:spcPts val="800"/>
+              </a:spcAft>
+            </a:pPr>
+            <a:r>
+              <a:rPr sz="1400" b="0">
                 <a:solidFill>
                   <a:srgbClr val="1C222B"/>
                 </a:solidFill>
                 <a:latin typeface="Calibri"/>
               </a:rPr>
-              <a:t>•  Hosted at triallens-ai.ai.studio. It still answers, and it still says TrialLens AI.</a:t>
-            </a:r>
-          </a:p>
-          <a:p>
-            <a:pPr algn="l">
-              <a:spcBef>
-                <a:spcPts val="0"/>
-              </a:spcBef>
-              <a:spcAft>
-                <a:spcPts val="900"/>
-              </a:spcAft>
-            </a:pPr>
-            <a:r>
-              <a:rPr sz="1500" b="0">
+              <a:t>•  The single-file host is still at triallens-ai.ai.studio, and it still says TrialLens AI.</a:t>
+            </a:r>
+          </a:p>
+          <a:p>
+            <a:pPr algn="l">
+              <a:spcBef>
+                <a:spcPts val="0"/>
+              </a:spcBef>
+              <a:spcAft>
+                <a:spcPts val="800"/>
+              </a:spcAft>
+            </a:pPr>
+            <a:r>
+              <a:rPr sz="1400" b="0">
                 <a:solidFill>
                   <a:srgbClr val="1C222B"/>
                 </a:solidFill>
                 <a:latin typeface="Calibri"/>
               </a:rPr>
-              <a:t>•  One file showed Overview, Assistant, documents, evaluation, and architecture.</a:t>
-            </a:r>
-          </a:p>
-          <a:p>
-            <a:pPr algn="l">
-              <a:spcBef>
-                <a:spcPts val="0"/>
-              </a:spcBef>
-              <a:spcAft>
-                <a:spcPts val="900"/>
-              </a:spcAft>
-            </a:pPr>
-            <a:r>
-              <a:rPr sz="1500" b="0">
+              <a:t>•  The published app says StudyCite. It opens on TL-301 Phase III, approved v3.0.</a:t>
+            </a:r>
+          </a:p>
+          <a:p>
+            <a:pPr algn="l">
+              <a:spcBef>
+                <a:spcPts val="0"/>
+              </a:spcBef>
+              <a:spcAft>
+                <a:spcPts val="800"/>
+              </a:spcAft>
+            </a:pPr>
+            <a:r>
+              <a:rPr sz="1400" b="0">
                 <a:solidFill>
                   <a:srgbClr val="1C222B"/>
                 </a:solidFill>
                 <a:latin typeface="Calibri"/>
               </a:rPr>
-              <a:t>•  Strength: no install, easy to react to, easy to share.</a:t>
-            </a:r>
-          </a:p>
-          <a:p>
-            <a:pPr algn="l">
-              <a:spcBef>
-                <a:spcPts val="0"/>
-              </a:spcBef>
-              <a:spcAft>
-                <a:spcPts val="900"/>
-              </a:spcAft>
-            </a:pPr>
-            <a:r>
-              <a:rPr sz="1500" b="0">
+              <a:t>•  Five pages: Overview, Assistant, documents, evaluation, and architecture.</a:t>
+            </a:r>
+          </a:p>
+          <a:p>
+            <a:pPr algn="l">
+              <a:spcBef>
+                <a:spcPts val="0"/>
+              </a:spcBef>
+              <a:spcAft>
+                <a:spcPts val="800"/>
+              </a:spcAft>
+            </a:pPr>
+            <a:r>
+              <a:rPr sz="1400" b="0">
                 <a:solidFill>
                   <a:srgbClr val="1C222B"/>
                 </a:solidFill>
                 <a:latin typeface="Calibri"/>
               </a:rPr>
-              <a:t>•  Limit: routing, types, and Git are hidden inside one document.</a:t>
+              <a:t>•  The 100%, 0%, and &lt; 2.0s lines on the overview are interface claims, not a measured study.</a:t>
             </a:r>
           </a:p>
         </p:txBody>
@@ -25092,7 +24849,7 @@
         <p:spPr>
           <a:xfrm>
             <a:off x="420624" y="5212080"/>
-            <a:ext cx="5349240" cy="1051560"/>
+            <a:ext cx="5349240" cy="1005840"/>
           </a:xfrm>
           <a:prstGeom prst="rect">
             <a:avLst/>
@@ -25112,20 +24869,20 @@
               </a:spcAft>
             </a:pPr>
             <a:r>
-              <a:rPr sz="1400" b="0">
-                <a:solidFill>
-                  <a:srgbClr val="5C6570"/>
-                </a:solidFill>
-                <a:latin typeface="Calibri"/>
-              </a:rPr>
-              <a:t>Hero numbers on that page are interface claims. They are not a measured study.</a:t>
+              <a:rPr sz="1300" b="1">
+                <a:solidFill>
+                  <a:srgbClr val="1A6A64"/>
+                </a:solidFill>
+                <a:latin typeface="Calibri"/>
+              </a:rPr>
+              <a:t>https://main.d18cernwuahm9n.amplifyapp.com</a:t>
             </a:r>
           </a:p>
         </p:txBody>
       </p:sp>
       <p:pic>
         <p:nvPicPr>
-          <p:cNvPr id="13" name="Picture 12" descr="studycite.png"/>
+          <p:cNvPr id="13" name="Picture 12" descr="studycite-overview.png"/>
           <p:cNvPicPr>
             <a:picLocks noChangeAspect="1"/>
           </p:cNvPicPr>
@@ -25155,8 +24912,8 @@
         </p:nvSpPr>
         <p:spPr>
           <a:xfrm>
-            <a:off x="5989320" y="4956048"/>
-            <a:ext cx="5760720" cy="640080"/>
+            <a:off x="5989320" y="4992624"/>
+            <a:ext cx="5760720" cy="777240"/>
           </a:xfrm>
           <a:prstGeom prst="rect">
             <a:avLst/>
@@ -25182,7 +24939,7 @@
                 </a:solidFill>
                 <a:latin typeface="Calibri"/>
               </a:rPr>
-              <a:t>Live prototype, October 18, 2026. Working title still on the page.</a:t>
+              <a:t>Published StudyCite, October 19, 2026. Amplify serves this build through CloudFront.</a:t>
             </a:r>
           </a:p>
         </p:txBody>

</xml_diff>